<commit_message>
up chage clase 1
</commit_message>
<xml_diff>
--- a/clases/clase_02/clase_02.pptx
+++ b/clases/clase_02/clase_02.pptx
@@ -3265,7 +3265,7 @@
         </p:nvSpPr>
         <p:spPr>
           <a:xfrm>
-            <a:off x="381300" y="685800"/>
+            <a:off x="381000" y="685800"/>
             <a:ext cx="6096000" cy="3429000"/>
           </a:xfrm>
           <a:custGeom>
@@ -18022,7 +18022,7 @@
         </p:spPr>
         <p:txBody>
           <a:bodyPr spcFirstLastPara="1" wrap="square" lIns="91425" tIns="91425" rIns="91425" bIns="91425" anchor="t" anchorCtr="0">
-            <a:normAutofit fontScale="70000" lnSpcReduction="20000"/>
+            <a:normAutofit fontScale="62500" lnSpcReduction="20000"/>
           </a:bodyPr>
           <a:lstStyle/>
           <a:p>
@@ -21761,7 +21761,7 @@
               <a:buNone/>
             </a:pPr>
             <a:r>
-              <a:rPr lang="es" sz="1405">
+              <a:rPr lang="es" sz="1405" dirty="0">
                 <a:latin typeface="EB Garamond"/>
                 <a:ea typeface="EB Garamond"/>
                 <a:cs typeface="EB Garamond"/>
@@ -21769,7 +21769,7 @@
               </a:rPr>
               <a:t>Profesora: Daniela Olivares Collío</a:t>
             </a:r>
-            <a:endParaRPr sz="1405">
+            <a:endParaRPr sz="1405" dirty="0">
               <a:latin typeface="EB Garamond"/>
               <a:ea typeface="EB Garamond"/>
               <a:cs typeface="EB Garamond"/>
@@ -21777,38 +21777,33 @@
             </a:endParaRPr>
           </a:p>
           <a:p>
-            <a:pPr marL="0" lvl="0" indent="0" algn="r" rtl="0">
+            <a:pPr marL="0" lvl="0" indent="0" algn="r">
               <a:lnSpc>
                 <a:spcPct val="80000"/>
               </a:lnSpc>
-              <a:spcBef>
-                <a:spcPts val="0"/>
-              </a:spcBef>
-              <a:spcAft>
-                <a:spcPts val="0"/>
-              </a:spcAft>
               <a:buClr>
                 <a:schemeClr val="dk1"/>
               </a:buClr>
               <a:buSzPts val="1018"/>
-              <a:buFont typeface="Arial"/>
-              <a:buNone/>
             </a:pPr>
             <a:r>
-              <a:rPr lang="es" sz="1405">
+              <a:rPr lang="es" sz="1405" dirty="0">
                 <a:latin typeface="EB Garamond"/>
                 <a:ea typeface="EB Garamond"/>
                 <a:cs typeface="EB Garamond"/>
                 <a:sym typeface="EB Garamond"/>
               </a:rPr>
-              <a:t>Ayudante: María Fernanda Núñez</a:t>
+              <a:t>Ayudante: </a:t>
             </a:r>
-            <a:endParaRPr sz="1405">
-              <a:latin typeface="EB Garamond"/>
-              <a:ea typeface="EB Garamond"/>
-              <a:cs typeface="EB Garamond"/>
-              <a:sym typeface="EB Garamond"/>
-            </a:endParaRPr>
+            <a:r>
+              <a:rPr lang="es-CL" sz="1405" dirty="0">
+                <a:latin typeface="EB Garamond"/>
+                <a:ea typeface="EB Garamond"/>
+                <a:cs typeface="EB Garamond"/>
+                <a:sym typeface="EB Garamond"/>
+              </a:rPr>
+              <a:t>Katherine Aravena Herrera</a:t>
+            </a:r>
           </a:p>
           <a:p>
             <a:pPr marL="0" lvl="0" indent="0" algn="r" rtl="0">
@@ -21829,7 +21824,7 @@
               <a:buNone/>
             </a:pPr>
             <a:r>
-              <a:rPr lang="es" sz="1405">
+              <a:rPr lang="es" sz="1405" dirty="0">
                 <a:latin typeface="EB Garamond"/>
                 <a:ea typeface="EB Garamond"/>
                 <a:cs typeface="EB Garamond"/>
@@ -21837,7 +21832,7 @@
               </a:rPr>
               <a:t>2do semestre 2026</a:t>
             </a:r>
-            <a:endParaRPr sz="1405">
+            <a:endParaRPr sz="1405" dirty="0">
               <a:latin typeface="EB Garamond"/>
               <a:ea typeface="EB Garamond"/>
               <a:cs typeface="EB Garamond"/>

</xml_diff>